<commit_message>
W07: error audit results (200 B2 errors, 4 annotators + AI pre-labels, adjudicated) + Review 2 slides 13–14
Co-Authored-By: Claude Opus 5.5 <noreply@anthropic.com>
Claude-Session: https://claude.ai/code/session_017zoFwkufMzvJQw5c1LpYxN
Co-authored-by: Cursor <cursoragent@cursor.com>
</commit_message>
<xml_diff>
--- a/docs/W07/ViVQA-VLM_Review2_EN.pptx
+++ b/docs/W07/ViVQA-VLM_Review2_EN.pptx
@@ -122,43 +122,43 @@
   <p:extLst>
     <p:ext uri="{521415D9-36F7-43E2-AB2F-B90AF26B5E84}">
       <p14:sectionLst xmlns:p14="http://schemas.microsoft.com/office/powerpoint/2010/main">
-        <p14:section name="Opening" id="{be3aa7f7-c5ed-0907-ea0a-97f57fec2728}">
+        <p14:section name="Opening" id="{2cbd35ed-fed4-c599-5707-db5722ff4e79}">
           <p14:sldIdLst>
             <p14:sldId id="256"/>
           </p14:sldIdLst>
         </p14:section>
-        <p14:section name="Summary" id="{ecd34f39-16a6-67e6-bf72-1a67ee8113e0}">
+        <p14:section name="Summary" id="{c3bbe5e6-5cee-5282-e94f-05f3ab3f69fa}">
           <p14:sldIdLst>
             <p14:sldId id="257"/>
           </p14:sldIdLst>
         </p14:section>
-        <p14:section name="Feedback" id="{38a5f4d5-8b91-f1fc-31cd-627fffff83ad}">
+        <p14:section name="Feedback" id="{7313a6b8-004e-7112-5cc0-73c660fe100f}">
           <p14:sldIdLst>
             <p14:sldId id="258"/>
           </p14:sldIdLst>
         </p14:section>
-        <p14:section name="Data &amp; baseline" id="{9a009395-c079-8bce-6e2e-6e8a6dd29438}">
+        <p14:section name="Data &amp; baseline" id="{8d07adf7-b27c-cdd0-1542-e6f232df1110}">
           <p14:sldIdLst>
             <p14:sldId id="259"/>
             <p14:sldId id="260"/>
             <p14:sldId id="261"/>
           </p14:sldIdLst>
         </p14:section>
-        <p14:section name="Results" id="{f0390466-b24e-5922-3f6b-f8ab7a515f4e}">
+        <p14:section name="Results" id="{9e29faf6-d535-e60f-0fd2-924f652703d9}">
           <p14:sldIdLst>
             <p14:sldId id="262"/>
             <p14:sldId id="263"/>
             <p14:sldId id="264"/>
           </p14:sldIdLst>
         </p14:section>
-        <p14:section name="Improvement" id="{b2d4b6c2-2806-b1c6-cb7a-2a7890a64e0b}">
+        <p14:section name="Improvement" id="{0efb8de8-83bc-80de-24cd-e7c01cf19643}">
           <p14:sldIdLst>
             <p14:sldId id="265"/>
             <p14:sldId id="266"/>
             <p14:sldId id="267"/>
           </p14:sldIdLst>
         </p14:section>
-        <p14:section name="Analysis &amp; plan" id="{ede2893f-e1fa-a9c2-3b7c-c8a3eef94536}">
+        <p14:section name="Analysis &amp; plan" id="{e269a539-991f-7b85-443d-5807ba6ffc33}">
           <p14:sldIdLst>
             <p14:sldId id="268"/>
             <p14:sldId id="269"/>
@@ -2484,7 +2484,7 @@
           <a:p>
             <a:r>
               <a:rPr lang="en-US" dirty="0"/>
-              <a:t>Đối chiếu với các giả thuyết đã nêu ở Review 1. H1 được ủng hộ mạnh. H2 chỉ đạt một nửa: VRAM giảm nhiều nhưng độ chính xác giữ 94,5%, dưới mức 97%. H7 chưa được ủng hộ với dạng few-shot đã thử. H8 về hallucination đang chờ kết quả duyệt tay. H3 đến H6 thuộc kế hoạch W8 đến W12.</a:t>
+              <a:t>Đối chiếu với các giả thuyết đã nêu ở Review 1. H1 được ủng hộ mạnh. H2 chỉ đạt một nửa: VRAM giảm nhiều nhưng độ chính xác giữ 94,5%, dưới mức 97%. H7 chưa được ủng hộ với dạng few-shot đã thử. H8: duyệt tay 200 lỗi của B2 cho thấy chỉ khoảng 7% là hallucination thật; nhưng H8 so sánh với zero-shot, nên cần đo thêm B1 ở tuần 11 — vì vậy vẫn để Đang chờ. H3 đến H6 thuộc kế hoạch W8 đến W12.</a:t>
             </a:r>
             <a:endParaRPr lang="en-US" dirty="0"/>
           </a:p>
@@ -2572,7 +2572,7 @@
           <a:p>
             <a:r>
               <a:rPr lang="en-US" dirty="0"/>
-              <a:t>Phân loại tự động 4.988 câu B2 còn sai trên full test ViTextVQA. 9% chỉ sai dấu thanh, ví dụ thủy và thúy — đây là thách thức riêng của tiếng Việt. 17% chỉ lệch một hai ký tự, thường là đọc chữ hoặc số. Khoảng 27% sai về độ dài: thừa hoặc thiếu chữ so với gold. 47% còn lại sai về nội dung hoặc vùng ảnh, cần duyệt tay để tách hallucination; nhóm đang duyệt tay 400 mẫu.</a:t>
+              <a:t>Phân loại tự động 4.988 câu B2 còn sai trên full test ViTextVQA. 9% chỉ sai dấu thanh, ví dụ thủy và thúy — đây là thách thức riêng của tiếng Việt. 17% chỉ lệch một hai ký tự, thường là đọc chữ hoặc số. Khoảng 27% sai về độ dài: thừa hoặc thiếu chữ so với gold. 47% còn lại sai về nội dung hoặc vùng ảnh. Nhóm đã duyệt tay 200 lỗi của B2 có xem ảnh, 4 người cùng nhãn gợi ý của AI, trưởng nhóm phân xử các chỗ lệch. Kết quả: 54% câu bị EM chấm sai thực ra đúng ý — EM quá khắt khe; 12,5% do gold nhiễu; ở ViTextVQA lỗi thật chủ yếu là đọc sai chữ 28% và đọc nhầm vùng chữ 23%; hallucination thật chỉ 7%. Độ đồng thuận giữa hai người gán nhãn độc lập kappa 0,62; bỏ 42 dòng có AI hỗ trợ thì kết luận không đổi.</a:t>
             </a:r>
             <a:endParaRPr lang="en-US" dirty="0"/>
           </a:p>
@@ -8836,7 +8836,7 @@
                           <a:ea typeface="Calibri" pitchFamily="34" charset="-122"/>
                           <a:cs typeface="Calibri" pitchFamily="34" charset="-120"/>
                         </a:rPr>
-                        <a:t>Manual audit of B2 errors in progress</a:t>
+                        <a:t>Audit: 7% of B2 errors are hallucinations (CI 4–11%); B1 comparison in W11</a:t>
                       </a:r>
                       <a:endParaRPr lang="en-US" sz="1400" dirty="0">
                         <a:latin typeface="Calibri" charset="0"/>
@@ -10276,7 +10276,7 @@
                 <a:ea typeface="Calibri" pitchFamily="34" charset="-122"/>
                 <a:cs typeface="Calibri" pitchFamily="34" charset="-120"/>
               </a:rPr>
-              <a:t>Manual audit (400 samples, in progress)</a:t>
+              <a:t>Manual audit: 200 B2 errors (adjudicated)</a:t>
             </a:r>
             <a:endParaRPr lang="en-US" sz="1600" dirty="0"/>
           </a:p>
@@ -10290,8 +10290,8 @@
         </p:nvSpPr>
         <p:spPr>
           <a:xfrm>
-            <a:off x="7589520" y="2286000"/>
-            <a:ext cx="3779215" cy="3840480"/>
+            <a:off x="7589520" y="2194560"/>
+            <a:ext cx="3779215" cy="3977640"/>
           </a:xfrm>
           <a:prstGeom prst="rect">
             <a:avLst/>
@@ -10311,7 +10311,7 @@
               <a:buChar char="•"/>
             </a:pPr>
             <a:r>
-              <a:rPr lang="en-US" sz="1400" dirty="0">
+              <a:rPr lang="en-US" sz="1500" dirty="0">
                 <a:solidFill>
                   <a:schemeClr val="tx1"/>
                 </a:solidFill>
@@ -10319,9 +10319,9 @@
                 <a:ea typeface="Calibri" pitchFamily="34" charset="-122"/>
                 <a:cs typeface="Calibri" pitchFamily="34" charset="-120"/>
               </a:rPr>
-              <a:t>200 B2 errors: format, synonym, OCR, tone marks, wrong region / hallucination, code-switching, counting, noisy gold</a:t>
+              <a:t>54% are correct in meaning: EM is too strict (ViVQA 62%, ViTextVQA 46%)</a:t>
             </a:r>
-            <a:endParaRPr lang="en-US" sz="1400" dirty="0"/>
+            <a:endParaRPr lang="en-US" sz="1500" dirty="0"/>
           </a:p>
           <a:p>
             <a:pPr marL="177800" indent="-177800">
@@ -10332,7 +10332,7 @@
               <a:buChar char="•"/>
             </a:pPr>
             <a:r>
-              <a:rPr lang="en-US" sz="1400" dirty="0">
+              <a:rPr lang="en-US" sz="1500" dirty="0">
                 <a:solidFill>
                   <a:schemeClr val="tx1"/>
                 </a:solidFill>
@@ -10340,9 +10340,9 @@
                 <a:ea typeface="Calibri" pitchFamily="34" charset="-122"/>
                 <a:cs typeface="Calibri" pitchFamily="34" charset="-120"/>
               </a:rPr>
-              <a:t>200 train labels: correct / wrong / ambiguous + noise type</a:t>
+              <a:t>Noisy gold: 12.5% (ViVQA 19%)</a:t>
             </a:r>
-            <a:endParaRPr lang="en-US" sz="1400" dirty="0"/>
+            <a:endParaRPr lang="en-US" sz="1500" dirty="0"/>
           </a:p>
           <a:p>
             <a:pPr marL="177800" indent="-177800">
@@ -10353,7 +10353,7 @@
               <a:buChar char="•"/>
             </a:pPr>
             <a:r>
-              <a:rPr lang="en-US" sz="1400" dirty="0">
+              <a:rPr lang="en-US" sz="1500" dirty="0">
                 <a:solidFill>
                   <a:schemeClr val="tx1"/>
                 </a:solidFill>
@@ -10361,9 +10361,9 @@
                 <a:ea typeface="Calibri" pitchFamily="34" charset="-122"/>
                 <a:cs typeface="Calibri" pitchFamily="34" charset="-120"/>
               </a:rPr>
-              <a:t>Separates hallucination inside the 47% “other” bucket → evidence for H8</a:t>
+              <a:t>ViTextVQA real errors: OCR 28%, wrong text region 23%, tone marks 8%</a:t>
             </a:r>
-            <a:endParaRPr lang="en-US" sz="1400" dirty="0"/>
+            <a:endParaRPr lang="en-US" sz="1500" dirty="0"/>
           </a:p>
           <a:p>
             <a:pPr marL="177800" indent="-177800">
@@ -10374,7 +10374,7 @@
               <a:buChar char="•"/>
             </a:pPr>
             <a:r>
-              <a:rPr lang="en-US" sz="1400" dirty="0">
+              <a:rPr lang="en-US" sz="1500" dirty="0">
                 <a:solidFill>
                   <a:schemeClr val="tx1"/>
                 </a:solidFill>
@@ -10382,9 +10382,30 @@
                 <a:ea typeface="Calibri" pitchFamily="34" charset="-122"/>
                 <a:cs typeface="Calibri" pitchFamily="34" charset="-120"/>
               </a:rPr>
-              <a:t>Deterministic sample (seed 42), images attached</a:t>
+              <a:t>Hallucination (not in the image): 7% of errors (95% CI 4–11%)</a:t>
             </a:r>
-            <a:endParaRPr lang="en-US" sz="1400" dirty="0"/>
+            <a:endParaRPr lang="en-US" sz="1500" dirty="0"/>
+          </a:p>
+          <a:p>
+            <a:pPr marL="177800" indent="-177800">
+              <a:spcAft>
+                <a:spcPts val="600"/>
+              </a:spcAft>
+              <a:buSzPct val="100000"/>
+              <a:buChar char="•"/>
+            </a:pPr>
+            <a:r>
+              <a:rPr lang="en-US" sz="1500" dirty="0">
+                <a:solidFill>
+                  <a:schemeClr val="tx1"/>
+                </a:solidFill>
+                <a:latin typeface="Calibri" pitchFamily="34" charset="0"/>
+                <a:ea typeface="Calibri" pitchFamily="34" charset="-122"/>
+                <a:cs typeface="Calibri" pitchFamily="34" charset="-120"/>
+              </a:rPr>
+              <a:t>4 annotators + AI pre-labels; κ = 0.62 (2 independent annotators); same conclusions without the 42 AI-assisted rows</a:t>
+            </a:r>
+            <a:endParaRPr lang="en-US" sz="1500" dirty="0"/>
           </a:p>
         </p:txBody>
       </p:sp>

</xml_diff>

<commit_message>
Review 2 deck: remove repository link from closing slide (replaced with reproducibility statement)
Co-authored-by: Cursor <cursoragent@cursor.com>
</commit_message>
<xml_diff>
--- a/docs/W07/ViVQA-VLM_Review2_EN.pptx
+++ b/docs/W07/ViVQA-VLM_Review2_EN.pptx
@@ -126,36 +126,36 @@
   <p:extLst>
     <p:ext uri="{521415D9-36F7-43E2-AB2F-B90AF26B5E84}">
       <p14:sectionLst xmlns:p14="http://schemas.microsoft.com/office/powerpoint/2010/main">
-        <p14:section name="Opening" id="{be74f817-0a59-5cc1-26c3-d58731a6bab7}">
+        <p14:section name="Opening" id="{b342503a-f970-5d44-fcb4-993182da0dab}">
           <p14:sldIdLst>
             <p14:sldId id="256"/>
           </p14:sldIdLst>
         </p14:section>
-        <p14:section name="Summary" id="{f1072e48-8469-a1af-a9cd-ae718bb981f2}">
+        <p14:section name="Summary" id="{df72d96d-0612-742e-c074-5ceb6831e722}">
           <p14:sldIdLst>
             <p14:sldId id="257"/>
           </p14:sldIdLst>
         </p14:section>
-        <p14:section name="Feedback" id="{dc632f28-2f38-9856-d6a4-449dd64f875d}">
+        <p14:section name="Feedback" id="{e76d6e5c-0bd3-3019-6fd8-72b1d4eaa12b}">
           <p14:sldIdLst>
             <p14:sldId id="258"/>
           </p14:sldIdLst>
         </p14:section>
-        <p14:section name="Data &amp; baseline" id="{b1893a6e-bcad-3781-c44d-35ce3423b43f}">
+        <p14:section name="Data &amp; baseline" id="{f7298292-9659-8944-23fb-526e371fe31f}">
           <p14:sldIdLst>
             <p14:sldId id="259"/>
             <p14:sldId id="260"/>
             <p14:sldId id="261"/>
           </p14:sldIdLst>
         </p14:section>
-        <p14:section name="Results" id="{58ce38aa-1582-6556-06a6-1005b0e51aeb}">
+        <p14:section name="Results" id="{8e304242-2c0c-7cec-56ca-734564eb0854}">
           <p14:sldIdLst>
             <p14:sldId id="262"/>
             <p14:sldId id="263"/>
             <p14:sldId id="264"/>
           </p14:sldIdLst>
         </p14:section>
-        <p14:section name="Improvement" id="{d76c3b3d-21ce-df14-4b39-1fc709706fcc}">
+        <p14:section name="Improvement" id="{7f6391ee-5d80-d7e0-bf40-b060a956a865}">
           <p14:sldIdLst>
             <p14:sldId id="265"/>
             <p14:sldId id="266"/>
@@ -163,7 +163,7 @@
             <p14:sldId id="268"/>
           </p14:sldIdLst>
         </p14:section>
-        <p14:section name="OCR-aware QLoRA" id="{9e2504bd-8294-6ec2-dd3c-d502f81c1f26}">
+        <p14:section name="OCR-aware QLoRA" id="{f3dd4afb-689b-a679-4a65-a57930a9ea94}">
           <p14:sldIdLst>
             <p14:sldId id="269"/>
             <p14:sldId id="270"/>
@@ -171,7 +171,7 @@
             <p14:sldId id="272"/>
           </p14:sldIdLst>
         </p14:section>
-        <p14:section name="Analysis &amp; plan" id="{3850f793-0b9f-fcb6-965e-472057ff18a3}">
+        <p14:section name="Analysis &amp; plan" id="{56ae33bd-7bd2-d980-225b-8eb8b7b4a12a}">
           <p14:sldIdLst>
             <p14:sldId id="273"/>
             <p14:sldId id="274"/>
@@ -17788,7 +17788,7 @@
                 <a:ea typeface="Calibri" pitchFamily="34" charset="-122"/>
                 <a:cs typeface="Calibri" pitchFamily="34" charset="-120"/>
               </a:rPr>
-              <a:t>Code, configs and every run log: github.com/PLHGNAOH/ViVQA-VLM</a:t>
+              <a:t>Every number in this talk comes from a logged, reproducible run (fixed seed, config and evaluation protocol).</a:t>
             </a:r>
             <a:endParaRPr lang="en-US" sz="1800" dirty="0"/>
           </a:p>

</xml_diff>